<commit_message>
feat: add Render deployment blueprint and update presentation with live URL https://cryptoguard-ai.onrender.com
</commit_message>
<xml_diff>
--- a/FINAL_SIH26182_CryptoGuard_AI_6_SLIDE.pptx
+++ b/FINAL_SIH26182_CryptoGuard_AI_6_SLIDE.pptx
@@ -6892,10 +6892,10 @@
             <a:r>
               <a:rPr sz="850">
                 <a:solidFill>
-                  <a:srgbClr val="64748B"/>
+                  <a:srgbClr val="2563EB"/>
                 </a:solidFill>
               </a:rPr>
-              <a:t>To be updated after deployment</a:t>
+              <a:t>https://cryptoguard-ai.onrender.com</a:t>
             </a:r>
           </a:p>
           <a:p>
@@ -10025,12 +10025,12 @@
               <a:t>Website: </a:t>
             </a:r>
             <a:r>
-              <a:rPr sz="900">
-                <a:solidFill>
-                  <a:srgbClr val="64748B"/>
+              <a:rPr b="1" sz="900">
+                <a:solidFill>
+                  <a:srgbClr val="2563EB"/>
                 </a:solidFill>
               </a:rPr>
-              <a:t>To be updated after deployment  |  </a:t>
+              <a:t>https://cryptoguard-ai.onrender.com  |  </a:t>
             </a:r>
             <a:r>
               <a:rPr b="1" sz="900">

</xml_diff>

<commit_message>
docs & pres: update live active deployment URL across slides and documentation
</commit_message>
<xml_diff>
--- a/FINAL_SIH26182_CryptoGuard_AI_6_SLIDE.pptx
+++ b/FINAL_SIH26182_CryptoGuard_AI_6_SLIDE.pptx
@@ -6895,7 +6895,7 @@
                   <a:srgbClr val="2563EB"/>
                 </a:solidFill>
               </a:rPr>
-              <a:t>https://cryptoguard-ai.onrender.com</a:t>
+              <a:t>https://clicks-prohibited-unity-relatively.trycloudflare.com</a:t>
             </a:r>
           </a:p>
           <a:p>
@@ -10030,7 +10030,7 @@
                   <a:srgbClr val="2563EB"/>
                 </a:solidFill>
               </a:rPr>
-              <a:t>https://cryptoguard-ai.onrender.com  |  </a:t>
+              <a:t>https://clicks-prohibited-unity-relatively.trycloudflare.com  |  </a:t>
             </a:r>
             <a:r>
               <a:rPr b="1" sz="900">

</xml_diff>

<commit_message>
docs & pres: embed verified working live URL into presentations and documentation
</commit_message>
<xml_diff>
--- a/FINAL_SIH26182_CryptoGuard_AI_6_SLIDE.pptx
+++ b/FINAL_SIH26182_CryptoGuard_AI_6_SLIDE.pptx
@@ -6895,7 +6895,7 @@
                   <a:srgbClr val="2563EB"/>
                 </a:solidFill>
               </a:rPr>
-              <a:t>https://clicks-prohibited-unity-relatively.trycloudflare.com</a:t>
+              <a:t>https://tubes-intersection-judicial-weapon.trycloudflare.com</a:t>
             </a:r>
           </a:p>
           <a:p>
@@ -10030,7 +10030,7 @@
                   <a:srgbClr val="2563EB"/>
                 </a:solidFill>
               </a:rPr>
-              <a:t>https://clicks-prohibited-unity-relatively.trycloudflare.com  |  </a:t>
+              <a:t>https://tubes-intersection-judicial-weapon.trycloudflare.com  |  </a:t>
             </a:r>
             <a:r>
               <a:rPr b="1" sz="900">

</xml_diff>

<commit_message>
pres: upgrade slide 1 title slide using generated SIH26182 title image
</commit_message>
<xml_diff>
--- a/FINAL_SIH26182_CryptoGuard_AI_6_SLIDE.pptx
+++ b/FINAL_SIH26182_CryptoGuard_AI_6_SLIDE.pptx
@@ -4665,72 +4665,9 @@
           <a:chExt cx="0" cy="0"/>
         </a:xfrm>
       </p:grpSpPr>
-      <p:sp>
-        <p:nvSpPr>
-          <p:cNvPr id="8" name="Title 7"/>
-          <p:cNvSpPr>
-            <a:spLocks noGrp="1"/>
-          </p:cNvSpPr>
-          <p:nvPr>
-            <p:ph type="ctrTitle"/>
-          </p:nvPr>
-        </p:nvSpPr>
-        <p:spPr>
-          <a:xfrm>
-            <a:off x="331286" y="-526757"/>
-            <a:ext cx="10363200" cy="2076450"/>
-          </a:xfrm>
-        </p:spPr>
-        <p:txBody>
-          <a:bodyPr/>
-          <a:lstStyle/>
-          <a:p>
-            <a:pPr>
-              <a:defRPr b="1" sz="2400">
-                <a:solidFill>
-                  <a:srgbClr val="0F2042"/>
-                </a:solidFill>
-              </a:defRPr>
-            </a:pPr>
-            <a:r>
-              <a:t>SMART INDIA HACKATHON 2026</a:t>
-            </a:r>
-          </a:p>
-        </p:txBody>
-      </p:sp>
       <p:pic>
         <p:nvPicPr>
-          <p:cNvPr id="2" name="Picture 1"/>
-          <p:cNvPicPr>
-            <a:picLocks noChangeAspect="1"/>
-          </p:cNvPicPr>
-          <p:nvPr/>
-        </p:nvPicPr>
-        <p:blipFill>
-          <a:blip r:embed="rId3">
-            <a:extLst>
-              <a:ext uri="{28A0092B-C50C-407E-A947-70E740481C1C}">
-                <a14:useLocalDpi xmlns:a14="http://schemas.microsoft.com/office/drawing/2010/main" val="0"/>
-              </a:ext>
-            </a:extLst>
-          </a:blip>
-          <a:stretch>
-            <a:fillRect/>
-          </a:stretch>
-        </p:blipFill>
-        <p:spPr>
-          <a:xfrm>
-            <a:off x="9780086" y="1500"/>
-            <a:ext cx="2249850" cy="1062337"/>
-          </a:xfrm>
-          <a:prstGeom prst="rect">
-            <a:avLst/>
-          </a:prstGeom>
-        </p:spPr>
-      </p:pic>
-      <p:pic>
-        <p:nvPicPr>
-          <p:cNvPr id="9" name="Picture 8" descr="page_1_img_1_X5.png"/>
+          <p:cNvPr id="2" name="Picture 1" descr="SIH26182_TITLE_SLIDE.png"/>
           <p:cNvPicPr>
             <a:picLocks noChangeAspect="1"/>
           </p:cNvPicPr>
@@ -4744,377 +4681,14 @@
         </p:blipFill>
         <p:spPr>
           <a:xfrm>
-            <a:off x="548640" y="109728"/>
-            <a:ext cx="2194560" cy="960120"/>
+            <a:off x="0" y="0"/>
+            <a:ext cx="12192000" cy="6858000"/>
           </a:xfrm>
           <a:prstGeom prst="rect">
             <a:avLst/>
           </a:prstGeom>
         </p:spPr>
       </p:pic>
-      <p:sp>
-        <p:nvSpPr>
-          <p:cNvPr id="10" name="Rounded Rectangle 9"/>
-          <p:cNvSpPr/>
-          <p:nvPr/>
-        </p:nvSpPr>
-        <p:spPr>
-          <a:xfrm>
-            <a:off x="548640" y="1417320"/>
-            <a:ext cx="6766560" cy="4663440"/>
-          </a:xfrm>
-          <a:prstGeom prst="roundRect">
-            <a:avLst/>
-          </a:prstGeom>
-          <a:solidFill>
-            <a:srgbClr val="FFFFFF"/>
-          </a:solidFill>
-          <a:ln w="19050">
-            <a:solidFill>
-              <a:srgbClr val="BFDBFE"/>
-            </a:solidFill>
-          </a:ln>
-        </p:spPr>
-        <p:style>
-          <a:lnRef idx="1">
-            <a:schemeClr val="accent1"/>
-          </a:lnRef>
-          <a:fillRef idx="3">
-            <a:schemeClr val="accent1"/>
-          </a:fillRef>
-          <a:effectRef idx="2">
-            <a:schemeClr val="accent1"/>
-          </a:effectRef>
-          <a:fontRef idx="minor">
-            <a:schemeClr val="lt1"/>
-          </a:fontRef>
-        </p:style>
-        <p:txBody>
-          <a:bodyPr rtlCol="0" anchor="ctr" wrap="square" lIns="256032" tIns="228600" rIns="256032"/>
-          <a:lstStyle/>
-          <a:p>
-            <a:pPr algn="ctr">
-              <a:spcAft>
-                <a:spcPts val="800"/>
-              </a:spcAft>
-              <a:defRPr b="1" sz="1500">
-                <a:solidFill>
-                  <a:srgbClr val="2563EB"/>
-                </a:solidFill>
-              </a:defRPr>
-            </a:pPr>
-            <a:r>
-              <a:t>Problem Statement ID: SIH26182</a:t>
-            </a:r>
-          </a:p>
-          <a:p>
-            <a:pPr>
-              <a:defRPr b="1" sz="1100">
-                <a:solidFill>
-                  <a:srgbClr val="334155"/>
-                </a:solidFill>
-              </a:defRPr>
-            </a:pPr>
-            <a:r>
-              <a:t>Problem Statement Title:</a:t>
-            </a:r>
-          </a:p>
-          <a:p>
-            <a:pPr>
-              <a:spcAft>
-                <a:spcPts val="1400"/>
-              </a:spcAft>
-              <a:defRPr b="1" sz="1300">
-                <a:solidFill>
-                  <a:srgbClr val="0F2042"/>
-                </a:solidFill>
-              </a:defRPr>
-            </a:pPr>
-            <a:r>
-              <a:t>Automated Attribution of Unknown Cryptocurrency Wallets to Nearest Virtual Asset Service Providers (VASPs) through Blockchain Intelligence APIs</a:t>
-            </a:r>
-          </a:p>
-          <a:p>
-            <a:pPr>
-              <a:spcAft>
-                <a:spcPts val="700"/>
-              </a:spcAft>
-            </a:pPr>
-            <a:r>
-              <a:rPr b="1" sz="1200">
-                <a:solidFill>
-                  <a:srgbClr val="334155"/>
-                </a:solidFill>
-              </a:rPr>
-              <a:t>Theme: </a:t>
-            </a:r>
-            <a:r>
-              <a:rPr b="0" sz="1200">
-                <a:solidFill>
-                  <a:srgbClr val="0F2042"/>
-                </a:solidFill>
-              </a:rPr>
-              <a:t>Blockchain &amp; Cybersecurity</a:t>
-            </a:r>
-          </a:p>
-          <a:p>
-            <a:pPr>
-              <a:spcAft>
-                <a:spcPts val="700"/>
-              </a:spcAft>
-            </a:pPr>
-            <a:r>
-              <a:rPr b="1" sz="1200">
-                <a:solidFill>
-                  <a:srgbClr val="334155"/>
-                </a:solidFill>
-              </a:rPr>
-              <a:t>PS Category: </a:t>
-            </a:r>
-            <a:r>
-              <a:rPr b="0" sz="1200">
-                <a:solidFill>
-                  <a:srgbClr val="0F2042"/>
-                </a:solidFill>
-              </a:rPr>
-              <a:t>Software</a:t>
-            </a:r>
-          </a:p>
-          <a:p>
-            <a:pPr>
-              <a:spcAft>
-                <a:spcPts val="700"/>
-              </a:spcAft>
-            </a:pPr>
-            <a:r>
-              <a:rPr b="1" sz="1200">
-                <a:solidFill>
-                  <a:srgbClr val="334155"/>
-                </a:solidFill>
-              </a:rPr>
-              <a:t>Team ID: </a:t>
-            </a:r>
-            <a:r>
-              <a:rPr b="0" sz="1200">
-                <a:solidFill>
-                  <a:srgbClr val="0F2042"/>
-                </a:solidFill>
-              </a:rPr>
-              <a:t>To be finalized on SIH Portal</a:t>
-            </a:r>
-          </a:p>
-          <a:p>
-            <a:pPr>
-              <a:spcAft>
-                <a:spcPts val="700"/>
-              </a:spcAft>
-            </a:pPr>
-            <a:r>
-              <a:rPr b="1" sz="1200">
-                <a:solidFill>
-                  <a:srgbClr val="334155"/>
-                </a:solidFill>
-              </a:rPr>
-              <a:t>Team Name (Registered): </a:t>
-            </a:r>
-            <a:r>
-              <a:rPr b="1" sz="1200">
-                <a:solidFill>
-                  <a:srgbClr val="0F2042"/>
-                </a:solidFill>
-              </a:rPr>
-              <a:t>CodeMesh</a:t>
-            </a:r>
-          </a:p>
-          <a:p>
-            <a:pPr>
-              <a:spcAft>
-                <a:spcPts val="700"/>
-              </a:spcAft>
-            </a:pPr>
-            <a:r>
-              <a:rPr b="1" sz="1200">
-                <a:solidFill>
-                  <a:srgbClr val="334155"/>
-                </a:solidFill>
-              </a:rPr>
-              <a:t>Project / Solution: </a:t>
-            </a:r>
-            <a:r>
-              <a:rPr b="1" sz="1350">
-                <a:solidFill>
-                  <a:srgbClr val="2563EB"/>
-                </a:solidFill>
-              </a:rPr>
-              <a:t>CryptoGuard AI</a:t>
-            </a:r>
-          </a:p>
-        </p:txBody>
-      </p:sp>
-      <p:sp>
-        <p:nvSpPr>
-          <p:cNvPr id="11" name="Rounded Rectangle 10"/>
-          <p:cNvSpPr/>
-          <p:nvPr/>
-        </p:nvSpPr>
-        <p:spPr>
-          <a:xfrm>
-            <a:off x="7543800" y="1417320"/>
-            <a:ext cx="4114800" cy="4663440"/>
-          </a:xfrm>
-          <a:prstGeom prst="roundRect">
-            <a:avLst/>
-          </a:prstGeom>
-          <a:solidFill>
-            <a:srgbClr val="EFF6FF"/>
-          </a:solidFill>
-          <a:ln w="19050">
-            <a:solidFill>
-              <a:srgbClr val="BFDBFE"/>
-            </a:solidFill>
-          </a:ln>
-        </p:spPr>
-        <p:style>
-          <a:lnRef idx="1">
-            <a:schemeClr val="accent1"/>
-          </a:lnRef>
-          <a:fillRef idx="3">
-            <a:schemeClr val="accent1"/>
-          </a:fillRef>
-          <a:effectRef idx="2">
-            <a:schemeClr val="accent1"/>
-          </a:effectRef>
-          <a:fontRef idx="minor">
-            <a:schemeClr val="lt1"/>
-          </a:fontRef>
-        </p:style>
-        <p:txBody>
-          <a:bodyPr rtlCol="0" anchor="ctr" wrap="square" lIns="228600" tIns="228600" rIns="228600"/>
-          <a:lstStyle/>
-          <a:p>
-            <a:pPr algn="ctr">
-              <a:spcAft>
-                <a:spcPts val="1000"/>
-              </a:spcAft>
-              <a:defRPr b="1" sz="1300">
-                <a:solidFill>
-                  <a:srgbClr val="0F2042"/>
-                </a:solidFill>
-              </a:defRPr>
-            </a:pPr>
-            <a:r>
-              <a:t>CRYPTOGUARD AI — SOLUTION BRIEF</a:t>
-            </a:r>
-          </a:p>
-          <a:p>
-            <a:pPr>
-              <a:spcAft>
-                <a:spcPts val="1200"/>
-              </a:spcAft>
-              <a:defRPr sz="1050">
-                <a:solidFill>
-                  <a:srgbClr val="334155"/>
-                </a:solidFill>
-              </a:defRPr>
-            </a:pPr>
-            <a:r>
-              <a:t>An automated, auditable blockchain investigation console empowering Indian Law Enforcement Agencies (LEAs) to trace illicit crypto flows and identify cashout exchanges.</a:t>
-            </a:r>
-          </a:p>
-          <a:p>
-            <a:pPr>
-              <a:spcAft>
-                <a:spcPts val="600"/>
-              </a:spcAft>
-            </a:pPr>
-            <a:r>
-              <a:rPr b="1" sz="1000">
-                <a:solidFill>
-                  <a:srgbClr val="1E3A8A"/>
-                </a:solidFill>
-              </a:rPr>
-              <a:t>• Multi-Chain Tracing: </a:t>
-            </a:r>
-            <a:r>
-              <a:rPr sz="950">
-                <a:solidFill>
-                  <a:srgbClr val="334155"/>
-                </a:solidFill>
-              </a:rPr>
-              <a:t>Directed BFS graph walk across Ethereum, BSC, Polygon, Tron, and Bitcoin.</a:t>
-            </a:r>
-          </a:p>
-          <a:p>
-            <a:pPr>
-              <a:spcAft>
-                <a:spcPts val="600"/>
-              </a:spcAft>
-            </a:pPr>
-            <a:r>
-              <a:rPr b="1" sz="1000">
-                <a:solidFill>
-                  <a:srgbClr val="1E3A8A"/>
-                </a:solidFill>
-              </a:rPr>
-              <a:t>• 4-Factor VASP Scoring: </a:t>
-            </a:r>
-            <a:r>
-              <a:rPr sz="950">
-                <a:solidFill>
-                  <a:srgbClr val="334155"/>
-                </a:solidFill>
-              </a:rPr>
-              <a:t>Proximity (40%), Volume (30%), Recency (20%), and Registry Trust (10%).</a:t>
-            </a:r>
-          </a:p>
-          <a:p>
-            <a:pPr>
-              <a:spcAft>
-                <a:spcPts val="600"/>
-              </a:spcAft>
-            </a:pPr>
-            <a:r>
-              <a:rPr b="1" sz="1000">
-                <a:solidFill>
-                  <a:srgbClr val="1E3A8A"/>
-                </a:solidFill>
-              </a:rPr>
-              <a:t>• 10-Signal AML Engine: </a:t>
-            </a:r>
-            <a:r>
-              <a:rPr sz="950">
-                <a:solidFill>
-                  <a:srgbClr val="334155"/>
-                </a:solidFill>
-              </a:rPr>
-              <a:t>Sanctions, mixers, peel chains, rapid exit, and structuring heuristics.</a:t>
-            </a:r>
-          </a:p>
-          <a:p>
-            <a:pPr>
-              <a:spcAft>
-                <a:spcPts val="600"/>
-              </a:spcAft>
-            </a:pPr>
-            <a:r>
-              <a:rPr b="1" sz="1000">
-                <a:solidFill>
-                  <a:srgbClr val="1E3A8A"/>
-                </a:solidFill>
-              </a:rPr>
-              <a:t>• Legal Workflow Integration: </a:t>
-            </a:r>
-            <a:r>
-              <a:rPr sz="950">
-                <a:solidFill>
-                  <a:srgbClr val="334155"/>
-                </a:solidFill>
-              </a:rPr>
-              <a:t>Automated Section 91 CrPC requisition notices &amp; court-admissible PDF reports.</a:t>
-            </a:r>
-          </a:p>
-        </p:txBody>
-      </p:sp>
     </p:spTree>
   </p:cSld>
   <p:clrMapOvr>

</xml_diff>